<commit_message>
fix(etiquetas): template H — accesorio antes de contenedor + recuadro que ajusta texto largo
Ajuste solicitado por Fernando: en la etiqueta de caja tipo H el orden del
contenido pasa a Producto -> Accesorio -> Contenedor -> Instructivo, y se
angosta/alarga el recuadro del contenido para que el texto largo del
contenedor quepa dentro de la etiqueta.

Co-Authored-By: Claude Opus 4.8 <noreply@anthropic.com>
</commit_message>
<xml_diff>
--- a/addons/amunet_label/static/templates/PLANTILLA_H.pptx
+++ b/addons/amunet_label/static/templates/PLANTILLA_H.pptx
@@ -3543,8 +3543,8 @@
           </p:nvSpPr>
           <p:spPr>
             <a:xfrm>
-              <a:off x="345616" y="783346"/>
-              <a:ext cx="2932347" cy="989438"/>
+              <a:off x="345617" y="783346"/>
+              <a:ext cx="2625118" cy="1243354"/>
             </a:xfrm>
             <a:prstGeom prst="rect">
               <a:avLst/>
@@ -3590,7 +3590,7 @@
                   <a:cs typeface="Now"/>
                   <a:sym typeface="Now"/>
                 </a:rPr>
-                <a:t>-{{N}} {{CONTENEDOR}}</a:t>
+                <a:t>-{{N}} {{ACCESORIO}}</a:t>
               </a:r>
             </a:p>
             <a:p>
@@ -3609,7 +3609,7 @@
                   <a:cs typeface="Now"/>
                   <a:sym typeface="Now"/>
                 </a:rPr>
-                <a:t>-{{N}} {{ACCESORIO}}</a:t>
+                <a:t>-{{N}} {{CONTENEDOR}}</a:t>
               </a:r>
             </a:p>
             <a:p>

</xml_diff>